<commit_message>
docs: update facilitator notes for clarity on session structure and demo preparation
</commit_message>
<xml_diff>
--- a/docs/Build_with_Gemini_RAG_Workshop.pptx
+++ b/docs/Build_with_Gemini_RAG_Workshop.pptx
@@ -3576,7 +3576,7 @@
                 <a:ea typeface="Trebuchet MS" pitchFamily="34" charset="-122"/>
                 <a:cs typeface="Trebuchet MS" pitchFamily="34" charset="-120"/>
               </a:rPr>
-              <a:t>Gemini 3 Pro</a:t>
+              <a:t>Gemini 3.1 Pro</a:t>
             </a:r>
             <a:endParaRPr lang="en-US" sz="1700" dirty="0"/>
           </a:p>
@@ -3727,7 +3727,7 @@
                 <a:ea typeface="Trebuchet MS" pitchFamily="34" charset="-122"/>
                 <a:cs typeface="Trebuchet MS" pitchFamily="34" charset="-120"/>
               </a:rPr>
-              <a:t>Gemini 3 Flash</a:t>
+              <a:t>Gemini 3.5 Flash</a:t>
             </a:r>
             <a:endParaRPr lang="en-US" sz="1700" dirty="0"/>
           </a:p>
@@ -6832,7 +6832,7 @@
                 <a:ea typeface="Calibri" pitchFamily="34" charset="-122"/>
                 <a:cs typeface="Calibri" pitchFamily="34" charset="-120"/>
               </a:rPr>
-              <a:t>Enable File Search → upload 1–3 files.</a:t>
+              <a:t>Attach 1–3 files with the + button.</a:t>
             </a:r>
             <a:endParaRPr lang="en-US" sz="1300" dirty="0"/>
           </a:p>

</xml_diff>